<commit_message>
Updated user guide's architecture figure
</commit_message>
<xml_diff>
--- a/doc/UserGuide/includes/illustrations.pptx
+++ b/doc/UserGuide/includes/illustrations.pptx
@@ -211,7 +211,7 @@
             <a:fld id="{BF2392DE-DA90-C84F-9F23-E5C230D67501}" type="datetimeFigureOut">
               <a:rPr lang="en-US" smtClean="0"/>
               <a:pPr/>
-              <a:t>1/12/18</a:t>
+              <a:t>6/16/26</a:t>
             </a:fld>
             <a:endParaRPr lang="en-US"/>
           </a:p>
@@ -277,38 +277,37 @@
           <a:p>
             <a:pPr lvl="0"/>
             <a:r>
-              <a:rPr lang="en-US" smtClean="0"/>
+              <a:rPr lang="en-US"/>
               <a:t>Click to edit Master text styles</a:t>
             </a:r>
           </a:p>
           <a:p>
             <a:pPr lvl="1"/>
             <a:r>
-              <a:rPr lang="en-US" smtClean="0"/>
+              <a:rPr lang="en-US"/>
               <a:t>Second level</a:t>
             </a:r>
           </a:p>
           <a:p>
             <a:pPr lvl="2"/>
             <a:r>
-              <a:rPr lang="en-US" smtClean="0"/>
+              <a:rPr lang="en-US"/>
               <a:t>Third level</a:t>
             </a:r>
           </a:p>
           <a:p>
             <a:pPr lvl="3"/>
             <a:r>
-              <a:rPr lang="en-US" smtClean="0"/>
+              <a:rPr lang="en-US"/>
               <a:t>Fourth level</a:t>
             </a:r>
           </a:p>
           <a:p>
             <a:pPr lvl="4"/>
             <a:r>
-              <a:rPr lang="en-US" smtClean="0"/>
+              <a:rPr lang="en-US"/>
               <a:t>Fifth level</a:t>
             </a:r>
-            <a:endParaRPr lang="en-US"/>
           </a:p>
         </p:txBody>
       </p:sp>
@@ -703,12 +702,8 @@
           <a:lstStyle/>
           <a:p>
             <a:r>
-              <a:rPr lang="en-US" sz="1000" dirty="0" smtClean="0"/>
-              <a:t>A Parliament database </a:t>
-            </a:r>
-            <a:r>
               <a:rPr lang="en-US" sz="1000" dirty="0"/>
-              <a:t>consists of four files:</a:t>
+              <a:t>A Parliament database consists of four files:</a:t>
             </a:r>
           </a:p>
           <a:p>
@@ -876,13 +871,8 @@
             </a:pPr>
             <a:r>
               <a:rPr lang="en-US" sz="1000" dirty="0"/>
-              <a:t>Also stores pointers to the next quad using each </a:t>
-            </a:r>
-            <a:r>
-              <a:rPr lang="en-US" sz="1000" dirty="0" smtClean="0"/>
-              <a:t>URI</a:t>
-            </a:r>
-            <a:endParaRPr lang="en-US" sz="1000" dirty="0"/>
+              <a:t>Also stores pointers to the next quad using each URI</a:t>
+            </a:r>
           </a:p>
         </p:txBody>
       </p:sp>
@@ -932,10 +922,9 @@
           <a:lstStyle/>
           <a:p>
             <a:r>
-              <a:rPr lang="en-US" smtClean="0"/>
+              <a:rPr lang="en-US"/>
               <a:t>Click to edit Master title style</a:t>
             </a:r>
-            <a:endParaRPr lang="en-US"/>
           </a:p>
         </p:txBody>
       </p:sp>
@@ -1051,10 +1040,9 @@
           </a:lstStyle>
           <a:p>
             <a:r>
-              <a:rPr lang="en-US" smtClean="0"/>
+              <a:rPr lang="en-US"/>
               <a:t>Click to edit Master subtitle style</a:t>
             </a:r>
-            <a:endParaRPr lang="en-US"/>
           </a:p>
         </p:txBody>
       </p:sp>
@@ -1076,7 +1064,7 @@
             <a:fld id="{08BFD309-D479-A847-B915-D65BB723EE4C}" type="datetimeFigureOut">
               <a:rPr lang="en-US" smtClean="0"/>
               <a:pPr/>
-              <a:t>1/12/18</a:t>
+              <a:t>6/16/26</a:t>
             </a:fld>
             <a:endParaRPr lang="en-US"/>
           </a:p>
@@ -1166,10 +1154,9 @@
           <a:lstStyle/>
           <a:p>
             <a:r>
-              <a:rPr lang="en-US" smtClean="0"/>
+              <a:rPr lang="en-US"/>
               <a:t>Click to edit Master title style</a:t>
             </a:r>
-            <a:endParaRPr lang="en-US"/>
           </a:p>
         </p:txBody>
       </p:sp>
@@ -1190,38 +1177,37 @@
           <a:p>
             <a:pPr lvl="0"/>
             <a:r>
-              <a:rPr lang="en-US" smtClean="0"/>
+              <a:rPr lang="en-US"/>
               <a:t>Click to edit Master text styles</a:t>
             </a:r>
           </a:p>
           <a:p>
             <a:pPr lvl="1"/>
             <a:r>
-              <a:rPr lang="en-US" smtClean="0"/>
+              <a:rPr lang="en-US"/>
               <a:t>Second level</a:t>
             </a:r>
           </a:p>
           <a:p>
             <a:pPr lvl="2"/>
             <a:r>
-              <a:rPr lang="en-US" smtClean="0"/>
+              <a:rPr lang="en-US"/>
               <a:t>Third level</a:t>
             </a:r>
           </a:p>
           <a:p>
             <a:pPr lvl="3"/>
             <a:r>
-              <a:rPr lang="en-US" smtClean="0"/>
+              <a:rPr lang="en-US"/>
               <a:t>Fourth level</a:t>
             </a:r>
           </a:p>
           <a:p>
             <a:pPr lvl="4"/>
             <a:r>
-              <a:rPr lang="en-US" smtClean="0"/>
+              <a:rPr lang="en-US"/>
               <a:t>Fifth level</a:t>
             </a:r>
-            <a:endParaRPr lang="en-US"/>
           </a:p>
         </p:txBody>
       </p:sp>
@@ -1243,7 +1229,7 @@
             <a:fld id="{08BFD309-D479-A847-B915-D65BB723EE4C}" type="datetimeFigureOut">
               <a:rPr lang="en-US" smtClean="0"/>
               <a:pPr/>
-              <a:t>1/12/18</a:t>
+              <a:t>6/16/26</a:t>
             </a:fld>
             <a:endParaRPr lang="en-US"/>
           </a:p>
@@ -1338,10 +1324,9 @@
           <a:lstStyle/>
           <a:p>
             <a:r>
-              <a:rPr lang="en-US" smtClean="0"/>
+              <a:rPr lang="en-US"/>
               <a:t>Click to edit Master title style</a:t>
             </a:r>
-            <a:endParaRPr lang="en-US"/>
           </a:p>
         </p:txBody>
       </p:sp>
@@ -1367,38 +1352,37 @@
           <a:p>
             <a:pPr lvl="0"/>
             <a:r>
-              <a:rPr lang="en-US" smtClean="0"/>
+              <a:rPr lang="en-US"/>
               <a:t>Click to edit Master text styles</a:t>
             </a:r>
           </a:p>
           <a:p>
             <a:pPr lvl="1"/>
             <a:r>
-              <a:rPr lang="en-US" smtClean="0"/>
+              <a:rPr lang="en-US"/>
               <a:t>Second level</a:t>
             </a:r>
           </a:p>
           <a:p>
             <a:pPr lvl="2"/>
             <a:r>
-              <a:rPr lang="en-US" smtClean="0"/>
+              <a:rPr lang="en-US"/>
               <a:t>Third level</a:t>
             </a:r>
           </a:p>
           <a:p>
             <a:pPr lvl="3"/>
             <a:r>
-              <a:rPr lang="en-US" smtClean="0"/>
+              <a:rPr lang="en-US"/>
               <a:t>Fourth level</a:t>
             </a:r>
           </a:p>
           <a:p>
             <a:pPr lvl="4"/>
             <a:r>
-              <a:rPr lang="en-US" smtClean="0"/>
+              <a:rPr lang="en-US"/>
               <a:t>Fifth level</a:t>
             </a:r>
-            <a:endParaRPr lang="en-US"/>
           </a:p>
         </p:txBody>
       </p:sp>
@@ -1420,7 +1404,7 @@
             <a:fld id="{08BFD309-D479-A847-B915-D65BB723EE4C}" type="datetimeFigureOut">
               <a:rPr lang="en-US" smtClean="0"/>
               <a:pPr/>
-              <a:t>1/12/18</a:t>
+              <a:t>6/16/26</a:t>
             </a:fld>
             <a:endParaRPr lang="en-US"/>
           </a:p>
@@ -1515,10 +1499,9 @@
           <a:lstStyle/>
           <a:p>
             <a:r>
-              <a:rPr lang="en-US" smtClean="0"/>
+              <a:rPr lang="en-US"/>
               <a:t>Click to edit Master title style</a:t>
             </a:r>
-            <a:endParaRPr lang="en-US"/>
           </a:p>
         </p:txBody>
       </p:sp>
@@ -1544,38 +1527,37 @@
           <a:p>
             <a:pPr lvl="0"/>
             <a:r>
-              <a:rPr lang="en-US" smtClean="0"/>
+              <a:rPr lang="en-US"/>
               <a:t>Click to edit Master text styles</a:t>
             </a:r>
           </a:p>
           <a:p>
             <a:pPr lvl="1"/>
             <a:r>
-              <a:rPr lang="en-US" smtClean="0"/>
+              <a:rPr lang="en-US"/>
               <a:t>Second level</a:t>
             </a:r>
           </a:p>
           <a:p>
             <a:pPr lvl="2"/>
             <a:r>
-              <a:rPr lang="en-US" smtClean="0"/>
+              <a:rPr lang="en-US"/>
               <a:t>Third level</a:t>
             </a:r>
           </a:p>
           <a:p>
             <a:pPr lvl="3"/>
             <a:r>
-              <a:rPr lang="en-US" smtClean="0"/>
+              <a:rPr lang="en-US"/>
               <a:t>Fourth level</a:t>
             </a:r>
           </a:p>
           <a:p>
             <a:pPr lvl="4"/>
             <a:r>
-              <a:rPr lang="en-US" smtClean="0"/>
+              <a:rPr lang="en-US"/>
               <a:t>Fifth level</a:t>
             </a:r>
-            <a:endParaRPr lang="en-US"/>
           </a:p>
         </p:txBody>
       </p:sp>
@@ -1601,38 +1583,37 @@
           <a:p>
             <a:pPr lvl="0"/>
             <a:r>
-              <a:rPr lang="en-US" smtClean="0"/>
+              <a:rPr lang="en-US"/>
               <a:t>Click to edit Master text styles</a:t>
             </a:r>
           </a:p>
           <a:p>
             <a:pPr lvl="1"/>
             <a:r>
-              <a:rPr lang="en-US" smtClean="0"/>
+              <a:rPr lang="en-US"/>
               <a:t>Second level</a:t>
             </a:r>
           </a:p>
           <a:p>
             <a:pPr lvl="2"/>
             <a:r>
-              <a:rPr lang="en-US" smtClean="0"/>
+              <a:rPr lang="en-US"/>
               <a:t>Third level</a:t>
             </a:r>
           </a:p>
           <a:p>
             <a:pPr lvl="3"/>
             <a:r>
-              <a:rPr lang="en-US" smtClean="0"/>
+              <a:rPr lang="en-US"/>
               <a:t>Fourth level</a:t>
             </a:r>
           </a:p>
           <a:p>
             <a:pPr lvl="4"/>
             <a:r>
-              <a:rPr lang="en-US" smtClean="0"/>
+              <a:rPr lang="en-US"/>
               <a:t>Fifth level</a:t>
             </a:r>
-            <a:endParaRPr lang="en-US"/>
           </a:p>
         </p:txBody>
       </p:sp>
@@ -1677,10 +1658,9 @@
           <a:lstStyle/>
           <a:p>
             <a:r>
-              <a:rPr lang="en-US" smtClean="0"/>
+              <a:rPr lang="en-US"/>
               <a:t>Click to edit Master title style</a:t>
             </a:r>
-            <a:endParaRPr lang="en-US"/>
           </a:p>
         </p:txBody>
       </p:sp>
@@ -1701,38 +1681,37 @@
           <a:p>
             <a:pPr lvl="0"/>
             <a:r>
-              <a:rPr lang="en-US" smtClean="0"/>
+              <a:rPr lang="en-US"/>
               <a:t>Click to edit Master text styles</a:t>
             </a:r>
           </a:p>
           <a:p>
             <a:pPr lvl="1"/>
             <a:r>
-              <a:rPr lang="en-US" smtClean="0"/>
+              <a:rPr lang="en-US"/>
               <a:t>Second level</a:t>
             </a:r>
           </a:p>
           <a:p>
             <a:pPr lvl="2"/>
             <a:r>
-              <a:rPr lang="en-US" smtClean="0"/>
+              <a:rPr lang="en-US"/>
               <a:t>Third level</a:t>
             </a:r>
           </a:p>
           <a:p>
             <a:pPr lvl="3"/>
             <a:r>
-              <a:rPr lang="en-US" smtClean="0"/>
+              <a:rPr lang="en-US"/>
               <a:t>Fourth level</a:t>
             </a:r>
           </a:p>
           <a:p>
             <a:pPr lvl="4"/>
             <a:r>
-              <a:rPr lang="en-US" smtClean="0"/>
+              <a:rPr lang="en-US"/>
               <a:t>Fifth level</a:t>
             </a:r>
-            <a:endParaRPr lang="en-US"/>
           </a:p>
         </p:txBody>
       </p:sp>
@@ -1754,7 +1733,7 @@
             <a:fld id="{08BFD309-D479-A847-B915-D65BB723EE4C}" type="datetimeFigureOut">
               <a:rPr lang="en-US" smtClean="0"/>
               <a:pPr/>
-              <a:t>1/12/18</a:t>
+              <a:t>6/16/26</a:t>
             </a:fld>
             <a:endParaRPr lang="en-US"/>
           </a:p>
@@ -1853,10 +1832,9 @@
           </a:lstStyle>
           <a:p>
             <a:r>
-              <a:rPr lang="en-US" smtClean="0"/>
+              <a:rPr lang="en-US"/>
               <a:t>Click to edit Master title style</a:t>
             </a:r>
-            <a:endParaRPr lang="en-US"/>
           </a:p>
         </p:txBody>
       </p:sp>
@@ -1973,7 +1951,7 @@
           <a:p>
             <a:pPr lvl="0"/>
             <a:r>
-              <a:rPr lang="en-US" smtClean="0"/>
+              <a:rPr lang="en-US"/>
               <a:t>Click to edit Master text styles</a:t>
             </a:r>
           </a:p>
@@ -1997,7 +1975,7 @@
             <a:fld id="{08BFD309-D479-A847-B915-D65BB723EE4C}" type="datetimeFigureOut">
               <a:rPr lang="en-US" smtClean="0"/>
               <a:pPr/>
-              <a:t>1/12/18</a:t>
+              <a:t>6/16/26</a:t>
             </a:fld>
             <a:endParaRPr lang="en-US"/>
           </a:p>
@@ -2087,10 +2065,9 @@
           <a:lstStyle/>
           <a:p>
             <a:r>
-              <a:rPr lang="en-US" smtClean="0"/>
+              <a:rPr lang="en-US"/>
               <a:t>Click to edit Master title style</a:t>
             </a:r>
-            <a:endParaRPr lang="en-US"/>
           </a:p>
         </p:txBody>
       </p:sp>
@@ -2144,38 +2121,37 @@
           <a:p>
             <a:pPr lvl="0"/>
             <a:r>
-              <a:rPr lang="en-US" smtClean="0"/>
+              <a:rPr lang="en-US"/>
               <a:t>Click to edit Master text styles</a:t>
             </a:r>
           </a:p>
           <a:p>
             <a:pPr lvl="1"/>
             <a:r>
-              <a:rPr lang="en-US" smtClean="0"/>
+              <a:rPr lang="en-US"/>
               <a:t>Second level</a:t>
             </a:r>
           </a:p>
           <a:p>
             <a:pPr lvl="2"/>
             <a:r>
-              <a:rPr lang="en-US" smtClean="0"/>
+              <a:rPr lang="en-US"/>
               <a:t>Third level</a:t>
             </a:r>
           </a:p>
           <a:p>
             <a:pPr lvl="3"/>
             <a:r>
-              <a:rPr lang="en-US" smtClean="0"/>
+              <a:rPr lang="en-US"/>
               <a:t>Fourth level</a:t>
             </a:r>
           </a:p>
           <a:p>
             <a:pPr lvl="4"/>
             <a:r>
-              <a:rPr lang="en-US" smtClean="0"/>
+              <a:rPr lang="en-US"/>
               <a:t>Fifth level</a:t>
             </a:r>
-            <a:endParaRPr lang="en-US"/>
           </a:p>
         </p:txBody>
       </p:sp>
@@ -2229,38 +2205,37 @@
           <a:p>
             <a:pPr lvl="0"/>
             <a:r>
-              <a:rPr lang="en-US" smtClean="0"/>
+              <a:rPr lang="en-US"/>
               <a:t>Click to edit Master text styles</a:t>
             </a:r>
           </a:p>
           <a:p>
             <a:pPr lvl="1"/>
             <a:r>
-              <a:rPr lang="en-US" smtClean="0"/>
+              <a:rPr lang="en-US"/>
               <a:t>Second level</a:t>
             </a:r>
           </a:p>
           <a:p>
             <a:pPr lvl="2"/>
             <a:r>
-              <a:rPr lang="en-US" smtClean="0"/>
+              <a:rPr lang="en-US"/>
               <a:t>Third level</a:t>
             </a:r>
           </a:p>
           <a:p>
             <a:pPr lvl="3"/>
             <a:r>
-              <a:rPr lang="en-US" smtClean="0"/>
+              <a:rPr lang="en-US"/>
               <a:t>Fourth level</a:t>
             </a:r>
           </a:p>
           <a:p>
             <a:pPr lvl="4"/>
             <a:r>
-              <a:rPr lang="en-US" smtClean="0"/>
+              <a:rPr lang="en-US"/>
               <a:t>Fifth level</a:t>
             </a:r>
-            <a:endParaRPr lang="en-US"/>
           </a:p>
         </p:txBody>
       </p:sp>
@@ -2282,7 +2257,7 @@
             <a:fld id="{08BFD309-D479-A847-B915-D65BB723EE4C}" type="datetimeFigureOut">
               <a:rPr lang="en-US" smtClean="0"/>
               <a:pPr/>
-              <a:t>1/12/18</a:t>
+              <a:t>6/16/26</a:t>
             </a:fld>
             <a:endParaRPr lang="en-US"/>
           </a:p>
@@ -2376,10 +2351,9 @@
           </a:lstStyle>
           <a:p>
             <a:r>
-              <a:rPr lang="en-US" smtClean="0"/>
+              <a:rPr lang="en-US"/>
               <a:t>Click to edit Master title style</a:t>
             </a:r>
-            <a:endParaRPr lang="en-US"/>
           </a:p>
         </p:txBody>
       </p:sp>
@@ -2442,7 +2416,7 @@
           <a:p>
             <a:pPr lvl="0"/>
             <a:r>
-              <a:rPr lang="en-US" smtClean="0"/>
+              <a:rPr lang="en-US"/>
               <a:t>Click to edit Master text styles</a:t>
             </a:r>
           </a:p>
@@ -2498,38 +2472,37 @@
           <a:p>
             <a:pPr lvl="0"/>
             <a:r>
-              <a:rPr lang="en-US" smtClean="0"/>
+              <a:rPr lang="en-US"/>
               <a:t>Click to edit Master text styles</a:t>
             </a:r>
           </a:p>
           <a:p>
             <a:pPr lvl="1"/>
             <a:r>
-              <a:rPr lang="en-US" smtClean="0"/>
+              <a:rPr lang="en-US"/>
               <a:t>Second level</a:t>
             </a:r>
           </a:p>
           <a:p>
             <a:pPr lvl="2"/>
             <a:r>
-              <a:rPr lang="en-US" smtClean="0"/>
+              <a:rPr lang="en-US"/>
               <a:t>Third level</a:t>
             </a:r>
           </a:p>
           <a:p>
             <a:pPr lvl="3"/>
             <a:r>
-              <a:rPr lang="en-US" smtClean="0"/>
+              <a:rPr lang="en-US"/>
               <a:t>Fourth level</a:t>
             </a:r>
           </a:p>
           <a:p>
             <a:pPr lvl="4"/>
             <a:r>
-              <a:rPr lang="en-US" smtClean="0"/>
+              <a:rPr lang="en-US"/>
               <a:t>Fifth level</a:t>
             </a:r>
-            <a:endParaRPr lang="en-US"/>
           </a:p>
         </p:txBody>
       </p:sp>
@@ -2592,7 +2565,7 @@
           <a:p>
             <a:pPr lvl="0"/>
             <a:r>
-              <a:rPr lang="en-US" smtClean="0"/>
+              <a:rPr lang="en-US"/>
               <a:t>Click to edit Master text styles</a:t>
             </a:r>
           </a:p>
@@ -2648,38 +2621,37 @@
           <a:p>
             <a:pPr lvl="0"/>
             <a:r>
-              <a:rPr lang="en-US" smtClean="0"/>
+              <a:rPr lang="en-US"/>
               <a:t>Click to edit Master text styles</a:t>
             </a:r>
           </a:p>
           <a:p>
             <a:pPr lvl="1"/>
             <a:r>
-              <a:rPr lang="en-US" smtClean="0"/>
+              <a:rPr lang="en-US"/>
               <a:t>Second level</a:t>
             </a:r>
           </a:p>
           <a:p>
             <a:pPr lvl="2"/>
             <a:r>
-              <a:rPr lang="en-US" smtClean="0"/>
+              <a:rPr lang="en-US"/>
               <a:t>Third level</a:t>
             </a:r>
           </a:p>
           <a:p>
             <a:pPr lvl="3"/>
             <a:r>
-              <a:rPr lang="en-US" smtClean="0"/>
+              <a:rPr lang="en-US"/>
               <a:t>Fourth level</a:t>
             </a:r>
           </a:p>
           <a:p>
             <a:pPr lvl="4"/>
             <a:r>
-              <a:rPr lang="en-US" smtClean="0"/>
+              <a:rPr lang="en-US"/>
               <a:t>Fifth level</a:t>
             </a:r>
-            <a:endParaRPr lang="en-US"/>
           </a:p>
         </p:txBody>
       </p:sp>
@@ -2701,7 +2673,7 @@
             <a:fld id="{08BFD309-D479-A847-B915-D65BB723EE4C}" type="datetimeFigureOut">
               <a:rPr lang="en-US" smtClean="0"/>
               <a:pPr/>
-              <a:t>1/12/18</a:t>
+              <a:t>6/16/26</a:t>
             </a:fld>
             <a:endParaRPr lang="en-US"/>
           </a:p>
@@ -2791,10 +2763,9 @@
           <a:lstStyle/>
           <a:p>
             <a:r>
-              <a:rPr lang="en-US" smtClean="0"/>
+              <a:rPr lang="en-US"/>
               <a:t>Click to edit Master title style</a:t>
             </a:r>
-            <a:endParaRPr lang="en-US"/>
           </a:p>
         </p:txBody>
       </p:sp>
@@ -2816,7 +2787,7 @@
             <a:fld id="{08BFD309-D479-A847-B915-D65BB723EE4C}" type="datetimeFigureOut">
               <a:rPr lang="en-US" smtClean="0"/>
               <a:pPr/>
-              <a:t>1/12/18</a:t>
+              <a:t>6/16/26</a:t>
             </a:fld>
             <a:endParaRPr lang="en-US"/>
           </a:p>
@@ -2908,7 +2879,7 @@
             <a:fld id="{08BFD309-D479-A847-B915-D65BB723EE4C}" type="datetimeFigureOut">
               <a:rPr lang="en-US" smtClean="0"/>
               <a:pPr/>
-              <a:t>1/12/18</a:t>
+              <a:t>6/16/26</a:t>
             </a:fld>
             <a:endParaRPr lang="en-US"/>
           </a:p>
@@ -3007,10 +2978,9 @@
           </a:lstStyle>
           <a:p>
             <a:r>
-              <a:rPr lang="en-US" smtClean="0"/>
+              <a:rPr lang="en-US"/>
               <a:t>Click to edit Master title style</a:t>
             </a:r>
-            <a:endParaRPr lang="en-US"/>
           </a:p>
         </p:txBody>
       </p:sp>
@@ -3064,38 +3034,37 @@
           <a:p>
             <a:pPr lvl="0"/>
             <a:r>
-              <a:rPr lang="en-US" smtClean="0"/>
+              <a:rPr lang="en-US"/>
               <a:t>Click to edit Master text styles</a:t>
             </a:r>
           </a:p>
           <a:p>
             <a:pPr lvl="1"/>
             <a:r>
-              <a:rPr lang="en-US" smtClean="0"/>
+              <a:rPr lang="en-US"/>
               <a:t>Second level</a:t>
             </a:r>
           </a:p>
           <a:p>
             <a:pPr lvl="2"/>
             <a:r>
-              <a:rPr lang="en-US" smtClean="0"/>
+              <a:rPr lang="en-US"/>
               <a:t>Third level</a:t>
             </a:r>
           </a:p>
           <a:p>
             <a:pPr lvl="3"/>
             <a:r>
-              <a:rPr lang="en-US" smtClean="0"/>
+              <a:rPr lang="en-US"/>
               <a:t>Fourth level</a:t>
             </a:r>
           </a:p>
           <a:p>
             <a:pPr lvl="4"/>
             <a:r>
-              <a:rPr lang="en-US" smtClean="0"/>
+              <a:rPr lang="en-US"/>
               <a:t>Fifth level</a:t>
             </a:r>
-            <a:endParaRPr lang="en-US"/>
           </a:p>
         </p:txBody>
       </p:sp>
@@ -3158,7 +3127,7 @@
           <a:p>
             <a:pPr lvl="0"/>
             <a:r>
-              <a:rPr lang="en-US" smtClean="0"/>
+              <a:rPr lang="en-US"/>
               <a:t>Click to edit Master text styles</a:t>
             </a:r>
           </a:p>
@@ -3182,7 +3151,7 @@
             <a:fld id="{08BFD309-D479-A847-B915-D65BB723EE4C}" type="datetimeFigureOut">
               <a:rPr lang="en-US" smtClean="0"/>
               <a:pPr/>
-              <a:t>1/12/18</a:t>
+              <a:t>6/16/26</a:t>
             </a:fld>
             <a:endParaRPr lang="en-US"/>
           </a:p>
@@ -3281,10 +3250,9 @@
           </a:lstStyle>
           <a:p>
             <a:r>
-              <a:rPr lang="en-US" smtClean="0"/>
+              <a:rPr lang="en-US"/>
               <a:t>Click to edit Master title style</a:t>
             </a:r>
-            <a:endParaRPr lang="en-US"/>
           </a:p>
         </p:txBody>
       </p:sp>
@@ -3408,7 +3376,7 @@
           <a:p>
             <a:pPr lvl="0"/>
             <a:r>
-              <a:rPr lang="en-US" smtClean="0"/>
+              <a:rPr lang="en-US"/>
               <a:t>Click to edit Master text styles</a:t>
             </a:r>
           </a:p>
@@ -3432,7 +3400,7 @@
             <a:fld id="{08BFD309-D479-A847-B915-D65BB723EE4C}" type="datetimeFigureOut">
               <a:rPr lang="en-US" smtClean="0"/>
               <a:pPr/>
-              <a:t>1/12/18</a:t>
+              <a:t>6/16/26</a:t>
             </a:fld>
             <a:endParaRPr lang="en-US"/>
           </a:p>
@@ -3537,10 +3505,9 @@
           <a:lstStyle/>
           <a:p>
             <a:r>
-              <a:rPr lang="en-US" smtClean="0"/>
+              <a:rPr lang="en-US"/>
               <a:t>Click to edit Master title style</a:t>
             </a:r>
-            <a:endParaRPr lang="en-US"/>
           </a:p>
         </p:txBody>
       </p:sp>
@@ -3571,38 +3538,37 @@
           <a:p>
             <a:pPr lvl="0"/>
             <a:r>
-              <a:rPr lang="en-US" smtClean="0"/>
+              <a:rPr lang="en-US"/>
               <a:t>Click to edit Master text styles</a:t>
             </a:r>
           </a:p>
           <a:p>
             <a:pPr lvl="1"/>
             <a:r>
-              <a:rPr lang="en-US" smtClean="0"/>
+              <a:rPr lang="en-US"/>
               <a:t>Second level</a:t>
             </a:r>
           </a:p>
           <a:p>
             <a:pPr lvl="2"/>
             <a:r>
-              <a:rPr lang="en-US" smtClean="0"/>
+              <a:rPr lang="en-US"/>
               <a:t>Third level</a:t>
             </a:r>
           </a:p>
           <a:p>
             <a:pPr lvl="3"/>
             <a:r>
-              <a:rPr lang="en-US" smtClean="0"/>
+              <a:rPr lang="en-US"/>
               <a:t>Fourth level</a:t>
             </a:r>
           </a:p>
           <a:p>
             <a:pPr lvl="4"/>
             <a:r>
-              <a:rPr lang="en-US" smtClean="0"/>
+              <a:rPr lang="en-US"/>
               <a:t>Fifth level</a:t>
             </a:r>
-            <a:endParaRPr lang="en-US"/>
           </a:p>
         </p:txBody>
       </p:sp>
@@ -3642,7 +3608,7 @@
             <a:fld id="{08BFD309-D479-A847-B915-D65BB723EE4C}" type="datetimeFigureOut">
               <a:rPr lang="en-US" smtClean="0"/>
               <a:pPr/>
-              <a:t>1/12/18</a:t>
+              <a:t>6/16/26</a:t>
             </a:fld>
             <a:endParaRPr lang="en-US"/>
           </a:p>
@@ -4032,10 +3998,9 @@
           <a:lstStyle/>
           <a:p>
             <a:r>
-              <a:rPr lang="en-US" dirty="0" smtClean="0"/>
+              <a:rPr lang="en-US" dirty="0"/>
               <a:t>Parliament™ Layers (1)</a:t>
             </a:r>
-            <a:endParaRPr lang="en-US" dirty="0"/>
           </a:p>
         </p:txBody>
       </p:sp>
@@ -4164,7 +4129,7 @@
           <a:lstStyle/>
           <a:p>
             <a:pPr algn="ctr"/>
-            <a:endParaRPr lang="en-US" b="0" dirty="0" smtClean="0">
+            <a:endParaRPr lang="en-US" b="0" dirty="0">
               <a:solidFill>
                 <a:schemeClr val="tx1"/>
               </a:solidFill>
@@ -4173,7 +4138,7 @@
           <a:p>
             <a:pPr algn="ctr"/>
             <a:r>
-              <a:rPr lang="en-US" b="0" dirty="0" smtClean="0">
+              <a:rPr lang="en-US" b="0" dirty="0">
                 <a:solidFill>
                   <a:schemeClr val="tx1"/>
                 </a:solidFill>
@@ -4233,7 +4198,7 @@
               </a:lnSpc>
             </a:pPr>
             <a:r>
-              <a:rPr lang="en-US" sz="1600" b="0" dirty="0" smtClean="0">
+              <a:rPr lang="en-US" sz="1600" b="0" dirty="0">
                 <a:solidFill>
                   <a:schemeClr val="tx1"/>
                 </a:solidFill>
@@ -4241,7 +4206,7 @@
               <a:t>Jetty + </a:t>
             </a:r>
             <a:r>
-              <a:rPr lang="en-US" sz="1600" b="0" dirty="0" err="1" smtClean="0">
+              <a:rPr lang="en-US" sz="1600" b="0" dirty="0" err="1">
                 <a:solidFill>
                   <a:schemeClr val="tx1"/>
                 </a:solidFill>
@@ -4301,18 +4266,13 @@
               </a:lnSpc>
             </a:pPr>
             <a:r>
-              <a:rPr lang="en-US" sz="1600" b="0" dirty="0" smtClean="0">
+              <a:rPr lang="en-US" sz="1600" b="0" dirty="0">
                 <a:solidFill>
                   <a:schemeClr val="tx1"/>
                 </a:solidFill>
               </a:rPr>
               <a:t>Jena</a:t>
             </a:r>
-            <a:endParaRPr lang="en-US" sz="1600" b="0" dirty="0">
-              <a:solidFill>
-                <a:schemeClr val="tx1"/>
-              </a:solidFill>
-            </a:endParaRPr>
           </a:p>
         </p:txBody>
       </p:sp>
@@ -4366,7 +4326,7 @@
           <a:p>
             <a:pPr algn="ctr"/>
             <a:r>
-              <a:rPr lang="en-US" sz="1400" b="0" dirty="0" smtClean="0">
+              <a:rPr lang="en-US" sz="1400" b="0" dirty="0">
                 <a:solidFill>
                   <a:schemeClr val="tx1"/>
                 </a:solidFill>
@@ -4374,7 +4334,7 @@
               <a:t>Jena </a:t>
             </a:r>
             <a:r>
-              <a:rPr lang="en-US" sz="1400" dirty="0" smtClean="0"/>
+              <a:rPr lang="en-US" sz="1400" dirty="0"/>
               <a:t>Graph for Parliament</a:t>
             </a:r>
             <a:endParaRPr lang="en-US" sz="1400" b="0" dirty="0">
@@ -4438,7 +4398,7 @@
                 <a:spcPct val="100000"/>
               </a:lnSpc>
             </a:pPr>
-            <a:endParaRPr lang="en-US" sz="1600" b="0" dirty="0" smtClean="0">
+            <a:endParaRPr lang="en-US" sz="1600" b="0" dirty="0">
               <a:solidFill>
                 <a:schemeClr val="tx1"/>
               </a:solidFill>
@@ -4451,20 +4411,12 @@
               </a:lnSpc>
             </a:pPr>
             <a:r>
-              <a:rPr lang="en-US" sz="1600" b="0" dirty="0" smtClean="0">
-                <a:solidFill>
-                  <a:schemeClr val="tx1"/>
-                </a:solidFill>
-              </a:rPr>
-              <a:t>Rule </a:t>
-            </a:r>
-            <a:r>
               <a:rPr lang="en-US" sz="1600" b="0" dirty="0">
                 <a:solidFill>
                   <a:schemeClr val="tx1"/>
                 </a:solidFill>
               </a:rPr>
-              <a:t>Engine</a:t>
+              <a:t>Rule Engine</a:t>
             </a:r>
           </a:p>
         </p:txBody>
@@ -4514,7 +4466,7 @@
               </a:lnSpc>
             </a:pPr>
             <a:r>
-              <a:rPr lang="en-US" sz="1800" b="0" dirty="0" smtClean="0">
+              <a:rPr lang="en-US" sz="1800" b="0" dirty="0">
                 <a:solidFill>
                   <a:schemeClr val="tx1"/>
                 </a:solidFill>
@@ -4574,7 +4526,7 @@
               </a:lnSpc>
             </a:pPr>
             <a:r>
-              <a:rPr lang="en-US" sz="1800" b="0" dirty="0" smtClean="0">
+              <a:rPr lang="en-US" sz="1800" b="0" dirty="0">
                 <a:solidFill>
                   <a:schemeClr val="tx1"/>
                 </a:solidFill>
@@ -4639,7 +4591,7 @@
           <a:p>
             <a:pPr algn="ctr"/>
             <a:r>
-              <a:rPr lang="en-US" sz="1400" b="0" dirty="0" smtClean="0">
+              <a:rPr lang="en-US" sz="1400" b="0" dirty="0">
                 <a:solidFill>
                   <a:schemeClr val="tx1"/>
                 </a:solidFill>
@@ -4647,7 +4599,7 @@
               <a:t>Sesame </a:t>
             </a:r>
             <a:r>
-              <a:rPr lang="en-US" sz="1400" dirty="0" smtClean="0"/>
+              <a:rPr lang="en-US" sz="1400" dirty="0"/>
               <a:t>SAIL for Parliament</a:t>
             </a:r>
             <a:endParaRPr lang="en-US" sz="1400" b="0" dirty="0">
@@ -4703,18 +4655,13 @@
               </a:lnSpc>
             </a:pPr>
             <a:r>
-              <a:rPr lang="en-US" sz="1600" b="0" dirty="0" smtClean="0">
+              <a:rPr lang="en-US" sz="1600" b="0" dirty="0">
                 <a:solidFill>
                   <a:schemeClr val="tx1"/>
                 </a:solidFill>
               </a:rPr>
               <a:t>Sesame</a:t>
             </a:r>
-            <a:endParaRPr lang="en-US" sz="1600" b="0" dirty="0">
-              <a:solidFill>
-                <a:schemeClr val="tx1"/>
-              </a:solidFill>
-            </a:endParaRPr>
           </a:p>
         </p:txBody>
       </p:sp>
@@ -4768,7 +4715,7 @@
           <a:p>
             <a:pPr algn="ctr"/>
             <a:r>
-              <a:rPr lang="en-US" sz="1400" b="0" dirty="0" smtClean="0">
+              <a:rPr lang="en-US" sz="1400" b="0" dirty="0">
                 <a:solidFill>
                   <a:schemeClr val="tx1"/>
                 </a:solidFill>
@@ -4776,7 +4723,7 @@
               <a:t>Jena </a:t>
             </a:r>
             <a:r>
-              <a:rPr lang="en-US" sz="1400" dirty="0" smtClean="0"/>
+              <a:rPr lang="en-US" sz="1400" dirty="0"/>
               <a:t>Graph for Indexes</a:t>
             </a:r>
             <a:endParaRPr lang="en-US" sz="1400" b="0" dirty="0">
@@ -4841,18 +4788,13 @@
               </a:lnSpc>
             </a:pPr>
             <a:r>
-              <a:rPr lang="en-US" sz="1600" b="0" dirty="0" smtClean="0">
+              <a:rPr lang="en-US" sz="1600" b="0" dirty="0">
                 <a:solidFill>
                   <a:schemeClr val="tx1"/>
                 </a:solidFill>
               </a:rPr>
               <a:t>Named Graph Support</a:t>
             </a:r>
-            <a:endParaRPr lang="en-US" sz="1600" b="0" dirty="0">
-              <a:solidFill>
-                <a:schemeClr val="tx1"/>
-              </a:solidFill>
-            </a:endParaRPr>
           </a:p>
         </p:txBody>
       </p:sp>
@@ -4910,18 +4852,13 @@
               </a:lnSpc>
             </a:pPr>
             <a:r>
-              <a:rPr lang="en-US" sz="1600" b="0" dirty="0" smtClean="0">
+              <a:rPr lang="en-US" sz="1600" b="0" dirty="0">
                 <a:solidFill>
                   <a:schemeClr val="tx1"/>
                 </a:solidFill>
               </a:rPr>
               <a:t>Temporal Index</a:t>
             </a:r>
-            <a:endParaRPr lang="en-US" sz="1600" b="0" dirty="0">
-              <a:solidFill>
-                <a:schemeClr val="tx1"/>
-              </a:solidFill>
-            </a:endParaRPr>
           </a:p>
         </p:txBody>
       </p:sp>
@@ -4979,18 +4916,13 @@
               </a:lnSpc>
             </a:pPr>
             <a:r>
-              <a:rPr lang="en-US" sz="1600" b="0" dirty="0" smtClean="0">
+              <a:rPr lang="en-US" sz="1600" b="0" dirty="0">
                 <a:solidFill>
                   <a:schemeClr val="tx1"/>
                 </a:solidFill>
               </a:rPr>
               <a:t>Geospatial Index</a:t>
             </a:r>
-            <a:endParaRPr lang="en-US" sz="1600" b="0" dirty="0">
-              <a:solidFill>
-                <a:schemeClr val="tx1"/>
-              </a:solidFill>
-            </a:endParaRPr>
           </a:p>
         </p:txBody>
       </p:sp>
@@ -5140,10 +5072,9 @@
           <a:lstStyle/>
           <a:p>
             <a:r>
-              <a:rPr lang="en-US" dirty="0" smtClean="0"/>
+              <a:rPr lang="en-US" dirty="0"/>
               <a:t>SPARQL</a:t>
             </a:r>
-            <a:endParaRPr lang="en-US" dirty="0"/>
           </a:p>
         </p:txBody>
       </p:sp>
@@ -5224,10 +5155,9 @@
           <a:lstStyle/>
           <a:p>
             <a:r>
-              <a:rPr lang="en-US" dirty="0" smtClean="0"/>
+              <a:rPr lang="en-US" dirty="0"/>
               <a:t>SERQL</a:t>
             </a:r>
-            <a:endParaRPr lang="en-US" dirty="0"/>
           </a:p>
         </p:txBody>
       </p:sp>
@@ -5350,10 +5280,9 @@
           <a:lstStyle/>
           <a:p>
             <a:r>
-              <a:rPr lang="en-US" dirty="0" smtClean="0"/>
+              <a:rPr lang="en-US" dirty="0"/>
               <a:t>C++</a:t>
             </a:r>
-            <a:endParaRPr lang="en-US" dirty="0"/>
           </a:p>
         </p:txBody>
       </p:sp>
@@ -5380,10 +5309,9 @@
           <a:lstStyle/>
           <a:p>
             <a:r>
-              <a:rPr lang="en-US" dirty="0" smtClean="0"/>
+              <a:rPr lang="en-US" dirty="0"/>
               <a:t>Java</a:t>
             </a:r>
-            <a:endParaRPr lang="en-US" dirty="0"/>
           </a:p>
         </p:txBody>
       </p:sp>
@@ -5432,18 +5360,13 @@
               </a:lnSpc>
             </a:pPr>
             <a:r>
-              <a:rPr lang="en-US" sz="1400" b="0" dirty="0" smtClean="0">
+              <a:rPr lang="en-US" sz="1400" b="0" dirty="0">
                 <a:solidFill>
                   <a:schemeClr val="tx1"/>
                 </a:solidFill>
               </a:rPr>
               <a:t>Third-Party Components</a:t>
             </a:r>
-            <a:endParaRPr lang="en-US" sz="1400" b="0" dirty="0">
-              <a:solidFill>
-                <a:schemeClr val="tx1"/>
-              </a:solidFill>
-            </a:endParaRPr>
           </a:p>
         </p:txBody>
       </p:sp>
@@ -5501,18 +5424,13 @@
               </a:lnSpc>
             </a:pPr>
             <a:r>
-              <a:rPr lang="en-US" sz="1400" b="0" dirty="0" smtClean="0">
+              <a:rPr lang="en-US" sz="1400" b="0" dirty="0">
                 <a:solidFill>
                   <a:schemeClr val="tx1"/>
                 </a:solidFill>
               </a:rPr>
               <a:t>Parliament Components</a:t>
             </a:r>
-            <a:endParaRPr lang="en-US" sz="1400" b="0" dirty="0">
-              <a:solidFill>
-                <a:schemeClr val="tx1"/>
-              </a:solidFill>
-            </a:endParaRPr>
           </a:p>
         </p:txBody>
       </p:sp>
@@ -5521,13 +5439,6 @@
   <p:clrMapOvr>
     <a:masterClrMapping/>
   </p:clrMapOvr>
-  <p:timing>
-    <p:tnLst>
-      <p:par>
-        <p:cTn id="1" dur="indefinite" restart="never" nodeType="tmRoot"/>
-      </p:par>
-    </p:tnLst>
-  </p:timing>
 </p:sld>
 </file>
 
@@ -5571,10 +5482,9 @@
           <a:lstStyle/>
           <a:p>
             <a:r>
-              <a:rPr lang="en-US" dirty="0" smtClean="0"/>
+              <a:rPr lang="en-US" dirty="0"/>
               <a:t>Parliament™ Architecture (2)</a:t>
             </a:r>
-            <a:endParaRPr lang="en-US" dirty="0"/>
           </a:p>
         </p:txBody>
       </p:sp>
@@ -5620,7 +5530,7 @@
           <a:lstStyle/>
           <a:p>
             <a:r>
-              <a:rPr lang="en-US" sz="1400" b="0" dirty="0" smtClean="0">
+              <a:rPr lang="en-US" sz="1400" b="0" dirty="0">
                 <a:solidFill>
                   <a:schemeClr val="tx1"/>
                 </a:solidFill>
@@ -5630,22 +5540,17 @@
           </a:p>
           <a:p>
             <a:r>
-              <a:rPr lang="en-US" sz="1400" dirty="0" smtClean="0"/>
+              <a:rPr lang="en-US" sz="1400" dirty="0"/>
               <a:t>Storage </a:t>
             </a:r>
             <a:r>
-              <a:rPr lang="en-US" sz="1400" b="0" dirty="0" smtClean="0">
+              <a:rPr lang="en-US" sz="1400" b="0" dirty="0">
                 <a:solidFill>
                   <a:schemeClr val="tx1"/>
                 </a:solidFill>
               </a:rPr>
               <a:t>Manager</a:t>
             </a:r>
-            <a:endParaRPr lang="en-US" sz="1400" b="0" dirty="0">
-              <a:solidFill>
-                <a:schemeClr val="tx1"/>
-              </a:solidFill>
-            </a:endParaRPr>
           </a:p>
         </p:txBody>
       </p:sp>
@@ -5661,143 +5566,6 @@
           <a:xfrm>
             <a:off x="2514600" y="2057400"/>
             <a:ext cx="3810000" cy="381000"/>
-          </a:xfrm>
-          <a:prstGeom prst="rect">
-            <a:avLst/>
-          </a:prstGeom>
-          <a:solidFill>
-            <a:schemeClr val="bg1">
-              <a:lumMod val="75000"/>
-            </a:schemeClr>
-          </a:solidFill>
-          <a:ln w="9525">
-            <a:solidFill>
-              <a:schemeClr val="tx1"/>
-            </a:solidFill>
-            <a:miter lim="800000"/>
-            <a:headEnd/>
-            <a:tailEnd/>
-          </a:ln>
-          <a:effectLst/>
-        </p:spPr>
-        <p:txBody>
-          <a:bodyPr vert="horz" wrap="square" lIns="91440" anchor="t" anchorCtr="0">
-            <a:prstTxWarp prst="textNoShape">
-              <a:avLst/>
-            </a:prstTxWarp>
-            <a:noAutofit/>
-          </a:bodyPr>
-          <a:lstStyle/>
-          <a:p>
-            <a:pPr eaLnBrk="1" hangingPunct="1">
-              <a:lnSpc>
-                <a:spcPct val="100000"/>
-              </a:lnSpc>
-            </a:pPr>
-            <a:r>
-              <a:rPr lang="en-US" sz="1400" b="0" dirty="0" smtClean="0">
-                <a:solidFill>
-                  <a:schemeClr val="tx1"/>
-                </a:solidFill>
-              </a:rPr>
-              <a:t>Web Interface (Jetty + </a:t>
-            </a:r>
-            <a:r>
-              <a:rPr lang="en-US" sz="1400" b="0" dirty="0" err="1" smtClean="0">
-                <a:solidFill>
-                  <a:schemeClr val="tx1"/>
-                </a:solidFill>
-              </a:rPr>
-              <a:t>Joseki</a:t>
-            </a:r>
-            <a:r>
-              <a:rPr lang="en-US" sz="1400" b="0" dirty="0" smtClean="0">
-                <a:solidFill>
-                  <a:schemeClr val="tx1"/>
-                </a:solidFill>
-              </a:rPr>
-              <a:t>)</a:t>
-            </a:r>
-            <a:endParaRPr lang="en-US" sz="1400" b="0" dirty="0">
-              <a:solidFill>
-                <a:schemeClr val="tx1"/>
-              </a:solidFill>
-            </a:endParaRPr>
-          </a:p>
-        </p:txBody>
-      </p:sp>
-      <p:sp>
-        <p:nvSpPr>
-          <p:cNvPr id="475152" name="Rectangle 16"/>
-          <p:cNvSpPr>
-            <a:spLocks noChangeArrowheads="1"/>
-          </p:cNvSpPr>
-          <p:nvPr/>
-        </p:nvSpPr>
-        <p:spPr bwMode="auto">
-          <a:xfrm>
-            <a:off x="2514600" y="2743200"/>
-            <a:ext cx="3810000" cy="838200"/>
-          </a:xfrm>
-          <a:prstGeom prst="rect">
-            <a:avLst/>
-          </a:prstGeom>
-          <a:solidFill>
-            <a:schemeClr val="bg1">
-              <a:lumMod val="75000"/>
-            </a:schemeClr>
-          </a:solidFill>
-          <a:ln w="9525">
-            <a:solidFill>
-              <a:schemeClr val="tx1"/>
-            </a:solidFill>
-            <a:miter lim="800000"/>
-            <a:headEnd/>
-            <a:tailEnd/>
-          </a:ln>
-          <a:effectLst/>
-        </p:spPr>
-        <p:txBody>
-          <a:bodyPr vert="horz" wrap="square" lIns="91440" anchor="t" anchorCtr="0">
-            <a:prstTxWarp prst="textNoShape">
-              <a:avLst/>
-            </a:prstTxWarp>
-            <a:noAutofit/>
-          </a:bodyPr>
-          <a:lstStyle/>
-          <a:p>
-            <a:r>
-              <a:rPr lang="en-US" sz="1400" dirty="0" smtClean="0"/>
-              <a:t>Query Processor (Jena </a:t>
-            </a:r>
-            <a:r>
-              <a:rPr lang="en-US" sz="1400" dirty="0"/>
-              <a:t>+ </a:t>
-            </a:r>
-            <a:r>
-              <a:rPr lang="en-US" sz="1400" dirty="0" smtClean="0"/>
-              <a:t>ARQ)</a:t>
-            </a:r>
-            <a:endParaRPr lang="en-US" sz="1400" b="0" dirty="0">
-              <a:solidFill>
-                <a:schemeClr val="tx1"/>
-              </a:solidFill>
-            </a:endParaRPr>
-          </a:p>
-        </p:txBody>
-      </p:sp>
-      <p:sp>
-        <p:nvSpPr>
-          <p:cNvPr id="475153" name="Rectangle 17" descr="Wide upward diagonal"/>
-          <p:cNvSpPr>
-            <a:spLocks noChangeArrowheads="1"/>
-          </p:cNvSpPr>
-          <p:nvPr/>
-        </p:nvSpPr>
-        <p:spPr bwMode="auto">
-          <a:xfrm>
-            <a:off x="2514600" y="3581400"/>
-            <a:ext cx="3810000" cy="304800"/>
           </a:xfrm>
           <a:prstGeom prst="rect">
             <a:avLst/>
@@ -5827,9 +5595,65 @@
           </a:bodyPr>
           <a:lstStyle/>
           <a:p>
-            <a:r>
-              <a:rPr lang="en-US" sz="1400" dirty="0" smtClean="0"/>
-              <a:t>Storage Adapter</a:t>
+            <a:pPr eaLnBrk="1" hangingPunct="1">
+              <a:lnSpc>
+                <a:spcPct val="100000"/>
+              </a:lnSpc>
+            </a:pPr>
+            <a:r>
+              <a:rPr lang="en-US" sz="1400" b="0" dirty="0">
+                <a:solidFill>
+                  <a:schemeClr val="tx1"/>
+                </a:solidFill>
+              </a:rPr>
+              <a:t>Web Interface</a:t>
+            </a:r>
+          </a:p>
+        </p:txBody>
+      </p:sp>
+      <p:sp>
+        <p:nvSpPr>
+          <p:cNvPr id="475152" name="Rectangle 16"/>
+          <p:cNvSpPr>
+            <a:spLocks noChangeArrowheads="1"/>
+          </p:cNvSpPr>
+          <p:nvPr/>
+        </p:nvSpPr>
+        <p:spPr bwMode="auto">
+          <a:xfrm>
+            <a:off x="2514600" y="2743200"/>
+            <a:ext cx="3810000" cy="838200"/>
+          </a:xfrm>
+          <a:prstGeom prst="rect">
+            <a:avLst/>
+          </a:prstGeom>
+          <a:solidFill>
+            <a:schemeClr val="bg1">
+              <a:lumMod val="75000"/>
+            </a:schemeClr>
+          </a:solidFill>
+          <a:ln w="9525">
+            <a:solidFill>
+              <a:schemeClr val="tx1"/>
+            </a:solidFill>
+            <a:miter lim="800000"/>
+            <a:headEnd/>
+            <a:tailEnd/>
+          </a:ln>
+          <a:effectLst/>
+        </p:spPr>
+        <p:txBody>
+          <a:bodyPr vert="horz" wrap="square" lIns="91440" anchor="t" anchorCtr="0">
+            <a:prstTxWarp prst="textNoShape">
+              <a:avLst/>
+            </a:prstTxWarp>
+            <a:noAutofit/>
+          </a:bodyPr>
+          <a:lstStyle/>
+          <a:p>
+            <a:r>
+              <a:rPr lang="en-US" sz="1400" dirty="0"/>
+              <a:t>Query Processor (Jena + ARQ)</a:t>
             </a:r>
             <a:endParaRPr lang="en-US" sz="1400" b="0" dirty="0">
               <a:solidFill>
@@ -5841,7 +5665,7 @@
       </p:sp>
       <p:sp>
         <p:nvSpPr>
-          <p:cNvPr id="475162" name="Rectangle 26" descr="Wide upward diagonal"/>
+          <p:cNvPr id="475153" name="Rectangle 17" descr="Wide upward diagonal"/>
           <p:cNvSpPr>
             <a:spLocks noChangeArrowheads="1"/>
           </p:cNvSpPr>
@@ -5849,8 +5673,8 @@
         </p:nvSpPr>
         <p:spPr bwMode="auto">
           <a:xfrm>
-            <a:off x="4876800" y="4038600"/>
-            <a:ext cx="1371600" cy="304800"/>
+            <a:off x="2514600" y="3581400"/>
+            <a:ext cx="3810000" cy="304800"/>
           </a:xfrm>
           <a:prstGeom prst="rect">
             <a:avLst/>
@@ -5880,18 +5704,9 @@
           </a:bodyPr>
           <a:lstStyle/>
           <a:p>
-            <a:pPr algn="ctr" eaLnBrk="1" hangingPunct="1">
-              <a:lnSpc>
-                <a:spcPct val="100000"/>
-              </a:lnSpc>
-            </a:pPr>
-            <a:r>
-              <a:rPr lang="en-US" sz="1400" b="0" dirty="0" smtClean="0">
-                <a:solidFill>
-                  <a:schemeClr val="tx1"/>
-                </a:solidFill>
-              </a:rPr>
-              <a:t>Rule Engine</a:t>
+            <a:r>
+              <a:rPr lang="en-US" sz="1400" dirty="0"/>
+              <a:t>Storage Adapter</a:t>
             </a:r>
             <a:endParaRPr lang="en-US" sz="1400" b="0" dirty="0">
               <a:solidFill>
@@ -5903,7 +5718,7 @@
       </p:sp>
       <p:sp>
         <p:nvSpPr>
-          <p:cNvPr id="29" name="Rectangle 27"/>
+          <p:cNvPr id="475162" name="Rectangle 26" descr="Wide upward diagonal"/>
           <p:cNvSpPr>
             <a:spLocks noChangeArrowheads="1"/>
           </p:cNvSpPr>
@@ -5911,130 +5726,8 @@
         </p:nvSpPr>
         <p:spPr bwMode="auto">
           <a:xfrm>
-            <a:off x="2514600" y="4495800"/>
-            <a:ext cx="3810000" cy="381000"/>
-          </a:xfrm>
-          <a:prstGeom prst="rect">
-            <a:avLst/>
-          </a:prstGeom>
-          <a:solidFill>
-            <a:schemeClr val="bg1">
-              <a:lumMod val="75000"/>
-            </a:schemeClr>
-          </a:solidFill>
-          <a:ln w="9525">
-            <a:solidFill>
-              <a:schemeClr val="tx1"/>
-            </a:solidFill>
-            <a:miter lim="800000"/>
-            <a:headEnd/>
-            <a:tailEnd/>
-          </a:ln>
-          <a:effectLst/>
-        </p:spPr>
-        <p:txBody>
-          <a:bodyPr vert="horz" wrap="square" lIns="91440" anchor="t" anchorCtr="0">
-            <a:prstTxWarp prst="textNoShape">
-              <a:avLst/>
-            </a:prstTxWarp>
-            <a:noAutofit/>
-          </a:bodyPr>
-          <a:lstStyle/>
-          <a:p>
-            <a:pPr eaLnBrk="1" hangingPunct="1">
-              <a:lnSpc>
-                <a:spcPct val="100000"/>
-              </a:lnSpc>
-            </a:pPr>
-            <a:r>
-              <a:rPr lang="en-US" sz="1400" b="0" dirty="0" smtClean="0">
-                <a:solidFill>
-                  <a:schemeClr val="tx1"/>
-                </a:solidFill>
-              </a:rPr>
-              <a:t>Operating System</a:t>
-            </a:r>
-            <a:endParaRPr lang="en-US" sz="1400" b="0" baseline="30000" dirty="0">
-              <a:solidFill>
-                <a:schemeClr val="tx1"/>
-              </a:solidFill>
-            </a:endParaRPr>
-          </a:p>
-        </p:txBody>
-      </p:sp>
-      <p:sp>
-        <p:nvSpPr>
-          <p:cNvPr id="475163" name="Rectangle 27"/>
-          <p:cNvSpPr>
-            <a:spLocks noChangeArrowheads="1"/>
-          </p:cNvSpPr>
-          <p:nvPr/>
-        </p:nvSpPr>
-        <p:spPr bwMode="auto">
-          <a:xfrm>
-            <a:off x="4876800" y="4495800"/>
+            <a:off x="4876800" y="4038600"/>
             <a:ext cx="1371600" cy="304800"/>
-          </a:xfrm>
-          <a:prstGeom prst="rect">
-            <a:avLst/>
-          </a:prstGeom>
-          <a:solidFill>
-            <a:schemeClr val="bg1">
-              <a:lumMod val="75000"/>
-            </a:schemeClr>
-          </a:solidFill>
-          <a:ln w="9525">
-            <a:solidFill>
-              <a:schemeClr val="tx1"/>
-            </a:solidFill>
-            <a:miter lim="800000"/>
-            <a:headEnd/>
-            <a:tailEnd/>
-          </a:ln>
-          <a:effectLst/>
-        </p:spPr>
-        <p:txBody>
-          <a:bodyPr vert="horz" wrap="square" lIns="91440" anchor="t" anchorCtr="0">
-            <a:prstTxWarp prst="textNoShape">
-              <a:avLst/>
-            </a:prstTxWarp>
-            <a:noAutofit/>
-          </a:bodyPr>
-          <a:lstStyle/>
-          <a:p>
-            <a:pPr algn="ctr" eaLnBrk="1" hangingPunct="1">
-              <a:lnSpc>
-                <a:spcPct val="100000"/>
-              </a:lnSpc>
-            </a:pPr>
-            <a:r>
-              <a:rPr lang="en-US" sz="1400" b="0" dirty="0" smtClean="0">
-                <a:solidFill>
-                  <a:schemeClr val="tx1"/>
-                </a:solidFill>
-              </a:rPr>
-              <a:t>Berkeley DB</a:t>
-            </a:r>
-            <a:endParaRPr lang="en-US" sz="1400" b="0" baseline="30000" dirty="0">
-              <a:solidFill>
-                <a:schemeClr val="tx1"/>
-              </a:solidFill>
-            </a:endParaRPr>
-          </a:p>
-        </p:txBody>
-      </p:sp>
-      <p:sp>
-        <p:nvSpPr>
-          <p:cNvPr id="33" name="Rectangle 17" descr="Wide upward diagonal"/>
-          <p:cNvSpPr>
-            <a:spLocks noChangeArrowheads="1"/>
-          </p:cNvSpPr>
-          <p:nvPr/>
-        </p:nvSpPr>
-        <p:spPr bwMode="auto">
-          <a:xfrm>
-            <a:off x="2514600" y="3276600"/>
-            <a:ext cx="1524000" cy="304800"/>
           </a:xfrm>
           <a:prstGeom prst="rect">
             <a:avLst/>
@@ -6064,11 +5757,76 @@
           </a:bodyPr>
           <a:lstStyle/>
           <a:p>
-            <a:r>
-              <a:rPr lang="en-US" sz="1400" dirty="0" smtClean="0"/>
-              <a:t>Index Adapter</a:t>
-            </a:r>
-            <a:endParaRPr lang="en-US" sz="1400" b="0" dirty="0">
+            <a:pPr algn="ctr" eaLnBrk="1" hangingPunct="1">
+              <a:lnSpc>
+                <a:spcPct val="100000"/>
+              </a:lnSpc>
+            </a:pPr>
+            <a:r>
+              <a:rPr lang="en-US" sz="1400" b="0" dirty="0">
+                <a:solidFill>
+                  <a:schemeClr val="tx1"/>
+                </a:solidFill>
+              </a:rPr>
+              <a:t>Rule Engine</a:t>
+            </a:r>
+          </a:p>
+        </p:txBody>
+      </p:sp>
+      <p:sp>
+        <p:nvSpPr>
+          <p:cNvPr id="29" name="Rectangle 27"/>
+          <p:cNvSpPr>
+            <a:spLocks noChangeArrowheads="1"/>
+          </p:cNvSpPr>
+          <p:nvPr/>
+        </p:nvSpPr>
+        <p:spPr bwMode="auto">
+          <a:xfrm>
+            <a:off x="2514600" y="4495800"/>
+            <a:ext cx="3810000" cy="381000"/>
+          </a:xfrm>
+          <a:prstGeom prst="rect">
+            <a:avLst/>
+          </a:prstGeom>
+          <a:solidFill>
+            <a:schemeClr val="bg1">
+              <a:lumMod val="75000"/>
+            </a:schemeClr>
+          </a:solidFill>
+          <a:ln w="9525">
+            <a:solidFill>
+              <a:schemeClr val="tx1"/>
+            </a:solidFill>
+            <a:miter lim="800000"/>
+            <a:headEnd/>
+            <a:tailEnd/>
+          </a:ln>
+          <a:effectLst/>
+        </p:spPr>
+        <p:txBody>
+          <a:bodyPr vert="horz" wrap="square" lIns="91440" anchor="t" anchorCtr="0">
+            <a:prstTxWarp prst="textNoShape">
+              <a:avLst/>
+            </a:prstTxWarp>
+            <a:noAutofit/>
+          </a:bodyPr>
+          <a:lstStyle/>
+          <a:p>
+            <a:pPr eaLnBrk="1" hangingPunct="1">
+              <a:lnSpc>
+                <a:spcPct val="100000"/>
+              </a:lnSpc>
+            </a:pPr>
+            <a:r>
+              <a:rPr lang="en-US" sz="1400" b="0" dirty="0">
+                <a:solidFill>
+                  <a:schemeClr val="tx1"/>
+                </a:solidFill>
+              </a:rPr>
+              <a:t>Operating System</a:t>
+            </a:r>
+            <a:endParaRPr lang="en-US" sz="1400" b="0" baseline="30000" dirty="0">
               <a:solidFill>
                 <a:schemeClr val="tx1"/>
               </a:solidFill>
@@ -6078,7 +5836,7 @@
       </p:sp>
       <p:sp>
         <p:nvSpPr>
-          <p:cNvPr id="34" name="Rectangle 17" descr="Wide upward diagonal"/>
+          <p:cNvPr id="475163" name="Rectangle 27"/>
           <p:cNvSpPr>
             <a:spLocks noChangeArrowheads="1"/>
           </p:cNvSpPr>
@@ -6086,8 +5844,69 @@
         </p:nvSpPr>
         <p:spPr bwMode="auto">
           <a:xfrm>
-            <a:off x="2514600" y="2438400"/>
-            <a:ext cx="3810000" cy="304800"/>
+            <a:off x="4876800" y="4495800"/>
+            <a:ext cx="1371600" cy="304800"/>
+          </a:xfrm>
+          <a:prstGeom prst="rect">
+            <a:avLst/>
+          </a:prstGeom>
+          <a:solidFill>
+            <a:schemeClr val="bg1">
+              <a:lumMod val="75000"/>
+            </a:schemeClr>
+          </a:solidFill>
+          <a:ln w="9525">
+            <a:solidFill>
+              <a:schemeClr val="tx1"/>
+            </a:solidFill>
+            <a:miter lim="800000"/>
+            <a:headEnd/>
+            <a:tailEnd/>
+          </a:ln>
+          <a:effectLst/>
+        </p:spPr>
+        <p:txBody>
+          <a:bodyPr vert="horz" wrap="square" lIns="91440" anchor="t" anchorCtr="0">
+            <a:prstTxWarp prst="textNoShape">
+              <a:avLst/>
+            </a:prstTxWarp>
+            <a:noAutofit/>
+          </a:bodyPr>
+          <a:lstStyle/>
+          <a:p>
+            <a:pPr algn="ctr" eaLnBrk="1" hangingPunct="1">
+              <a:lnSpc>
+                <a:spcPct val="100000"/>
+              </a:lnSpc>
+            </a:pPr>
+            <a:r>
+              <a:rPr lang="en-US" sz="1400" b="0" dirty="0" err="1">
+                <a:solidFill>
+                  <a:schemeClr val="tx1"/>
+                </a:solidFill>
+              </a:rPr>
+              <a:t>RocksDB</a:t>
+            </a:r>
+            <a:endParaRPr lang="en-US" sz="1400" b="0" baseline="30000" dirty="0">
+              <a:solidFill>
+                <a:schemeClr val="tx1"/>
+              </a:solidFill>
+            </a:endParaRPr>
+          </a:p>
+        </p:txBody>
+      </p:sp>
+      <p:sp>
+        <p:nvSpPr>
+          <p:cNvPr id="33" name="Rectangle 17" descr="Wide upward diagonal"/>
+          <p:cNvSpPr>
+            <a:spLocks noChangeArrowheads="1"/>
+          </p:cNvSpPr>
+          <p:nvPr/>
+        </p:nvSpPr>
+        <p:spPr bwMode="auto">
+          <a:xfrm>
+            <a:off x="2514600" y="3276600"/>
+            <a:ext cx="1524000" cy="304800"/>
           </a:xfrm>
           <a:prstGeom prst="rect">
             <a:avLst/>
@@ -6117,18 +5936,9 @@
           </a:bodyPr>
           <a:lstStyle/>
           <a:p>
-            <a:pPr eaLnBrk="1" hangingPunct="1">
-              <a:lnSpc>
-                <a:spcPct val="100000"/>
-              </a:lnSpc>
-            </a:pPr>
-            <a:r>
-              <a:rPr lang="en-US" sz="1400" b="0" dirty="0" smtClean="0">
-                <a:solidFill>
-                  <a:schemeClr val="tx1"/>
-                </a:solidFill>
-              </a:rPr>
-              <a:t>Named Graph Support</a:t>
+            <a:r>
+              <a:rPr lang="en-US" sz="1400" dirty="0"/>
+              <a:t>Index Adapter</a:t>
             </a:r>
             <a:endParaRPr lang="en-US" sz="1400" b="0" dirty="0">
               <a:solidFill>
@@ -6140,7 +5950,7 @@
       </p:sp>
       <p:sp>
         <p:nvSpPr>
-          <p:cNvPr id="35" name="Rectangle 17" descr="Wide upward diagonal"/>
+          <p:cNvPr id="34" name="Rectangle 17" descr="Wide upward diagonal"/>
           <p:cNvSpPr>
             <a:spLocks noChangeArrowheads="1"/>
           </p:cNvSpPr>
@@ -6148,8 +5958,8 @@
         </p:nvSpPr>
         <p:spPr bwMode="auto">
           <a:xfrm>
-            <a:off x="1219200" y="2743200"/>
-            <a:ext cx="990600" cy="533400"/>
+            <a:off x="2514600" y="2438400"/>
+            <a:ext cx="3810000" cy="304800"/>
           </a:xfrm>
           <a:prstGeom prst="rect">
             <a:avLst/>
@@ -6179,30 +5989,25 @@
           </a:bodyPr>
           <a:lstStyle/>
           <a:p>
-            <a:pPr algn="ctr" eaLnBrk="1" hangingPunct="1">
+            <a:pPr eaLnBrk="1" hangingPunct="1">
               <a:lnSpc>
                 <a:spcPct val="100000"/>
               </a:lnSpc>
             </a:pPr>
             <a:r>
-              <a:rPr lang="en-US" sz="1400" b="0" dirty="0" smtClean="0">
+              <a:rPr lang="en-US" sz="1400" b="0" dirty="0">
                 <a:solidFill>
                   <a:schemeClr val="tx1"/>
                 </a:solidFill>
               </a:rPr>
-              <a:t>Temporal Index</a:t>
-            </a:r>
-            <a:endParaRPr lang="en-US" sz="1400" b="0" dirty="0">
-              <a:solidFill>
-                <a:schemeClr val="tx1"/>
-              </a:solidFill>
-            </a:endParaRPr>
-          </a:p>
-        </p:txBody>
-      </p:sp>
-      <p:sp>
-        <p:nvSpPr>
-          <p:cNvPr id="36" name="Rectangle 17" descr="Wide upward diagonal"/>
+              <a:t>Named Graph Support</a:t>
+            </a:r>
+          </a:p>
+        </p:txBody>
+      </p:sp>
+      <p:sp>
+        <p:nvSpPr>
+          <p:cNvPr id="35" name="Rectangle 17" descr="Wide upward diagonal"/>
           <p:cNvSpPr>
             <a:spLocks noChangeArrowheads="1"/>
           </p:cNvSpPr>
@@ -6210,7 +6015,7 @@
         </p:nvSpPr>
         <p:spPr bwMode="auto">
           <a:xfrm>
-            <a:off x="1219200" y="3352800"/>
+            <a:off x="1219200" y="2743200"/>
             <a:ext cx="990600" cy="533400"/>
           </a:xfrm>
           <a:prstGeom prst="rect">
@@ -6247,18 +6052,70 @@
               </a:lnSpc>
             </a:pPr>
             <a:r>
-              <a:rPr lang="en-US" sz="1400" b="0" dirty="0" smtClean="0">
+              <a:rPr lang="en-US" sz="1400" b="0" dirty="0">
+                <a:solidFill>
+                  <a:schemeClr val="tx1"/>
+                </a:solidFill>
+              </a:rPr>
+              <a:t>Temporal Index</a:t>
+            </a:r>
+          </a:p>
+        </p:txBody>
+      </p:sp>
+      <p:sp>
+        <p:nvSpPr>
+          <p:cNvPr id="36" name="Rectangle 17" descr="Wide upward diagonal"/>
+          <p:cNvSpPr>
+            <a:spLocks noChangeArrowheads="1"/>
+          </p:cNvSpPr>
+          <p:nvPr/>
+        </p:nvSpPr>
+        <p:spPr bwMode="auto">
+          <a:xfrm>
+            <a:off x="1219200" y="3352800"/>
+            <a:ext cx="990600" cy="533400"/>
+          </a:xfrm>
+          <a:prstGeom prst="rect">
+            <a:avLst/>
+          </a:prstGeom>
+          <a:solidFill>
+            <a:schemeClr val="accent1">
+              <a:lumMod val="60000"/>
+              <a:lumOff val="40000"/>
+            </a:schemeClr>
+          </a:solidFill>
+          <a:ln w="9525">
+            <a:solidFill>
+              <a:schemeClr val="tx1"/>
+            </a:solidFill>
+            <a:miter lim="800000"/>
+            <a:headEnd/>
+            <a:tailEnd/>
+          </a:ln>
+          <a:effectLst/>
+        </p:spPr>
+        <p:txBody>
+          <a:bodyPr vert="horz" wrap="square" lIns="91440" anchor="t" anchorCtr="0">
+            <a:prstTxWarp prst="textNoShape">
+              <a:avLst/>
+            </a:prstTxWarp>
+            <a:noAutofit/>
+          </a:bodyPr>
+          <a:lstStyle/>
+          <a:p>
+            <a:pPr algn="ctr" eaLnBrk="1" hangingPunct="1">
+              <a:lnSpc>
+                <a:spcPct val="100000"/>
+              </a:lnSpc>
+            </a:pPr>
+            <a:r>
+              <a:rPr lang="en-US" sz="1400" b="0" dirty="0">
                 <a:solidFill>
                   <a:schemeClr val="tx1"/>
                 </a:solidFill>
               </a:rPr>
               <a:t>Geospatial Index</a:t>
             </a:r>
-            <a:endParaRPr lang="en-US" sz="1400" b="0" dirty="0">
-              <a:solidFill>
-                <a:schemeClr val="tx1"/>
-              </a:solidFill>
-            </a:endParaRPr>
           </a:p>
         </p:txBody>
       </p:sp>
@@ -6419,10 +6276,9 @@
           <a:lstStyle/>
           <a:p>
             <a:r>
-              <a:rPr lang="en-US" sz="1400" dirty="0" smtClean="0"/>
+              <a:rPr lang="en-US" sz="1400" dirty="0"/>
               <a:t>SPARQL Queries</a:t>
             </a:r>
-            <a:endParaRPr lang="en-US" sz="1400" dirty="0"/>
           </a:p>
         </p:txBody>
       </p:sp>
@@ -6548,10 +6404,9 @@
           <a:lstStyle/>
           <a:p>
             <a:r>
-              <a:rPr lang="en-US" sz="1400" dirty="0" smtClean="0"/>
+              <a:rPr lang="en-US" sz="1400" dirty="0"/>
               <a:t>C++</a:t>
             </a:r>
-            <a:endParaRPr lang="en-US" sz="1400" dirty="0"/>
           </a:p>
         </p:txBody>
       </p:sp>
@@ -6578,10 +6433,9 @@
           <a:lstStyle/>
           <a:p>
             <a:r>
-              <a:rPr lang="en-US" sz="1400" dirty="0" smtClean="0"/>
+              <a:rPr lang="en-US" sz="1400" dirty="0"/>
               <a:t>Java</a:t>
             </a:r>
-            <a:endParaRPr lang="en-US" sz="1400" dirty="0"/>
           </a:p>
         </p:txBody>
       </p:sp>
@@ -6631,7 +6485,7 @@
               </a:lnSpc>
             </a:pPr>
             <a:r>
-              <a:rPr lang="en-US" sz="1400" b="0" dirty="0" smtClean="0">
+              <a:rPr lang="en-US" sz="1400" b="0" dirty="0">
                 <a:solidFill>
                   <a:schemeClr val="tx1"/>
                 </a:solidFill>
@@ -6639,7 +6493,7 @@
               <a:t>3</a:t>
             </a:r>
             <a:r>
-              <a:rPr lang="en-US" sz="1400" b="0" baseline="30000" dirty="0" smtClean="0">
+              <a:rPr lang="en-US" sz="1400" b="0" baseline="30000" dirty="0">
                 <a:solidFill>
                   <a:schemeClr val="tx1"/>
                 </a:solidFill>
@@ -6647,18 +6501,13 @@
               <a:t>rd</a:t>
             </a:r>
             <a:r>
-              <a:rPr lang="en-US" sz="1400" b="0" dirty="0" smtClean="0">
+              <a:rPr lang="en-US" sz="1400" b="0" dirty="0">
                 <a:solidFill>
                   <a:schemeClr val="tx1"/>
                 </a:solidFill>
               </a:rPr>
               <a:t>-Party Components</a:t>
             </a:r>
-            <a:endParaRPr lang="en-US" sz="1400" b="0" dirty="0">
-              <a:solidFill>
-                <a:schemeClr val="tx1"/>
-              </a:solidFill>
-            </a:endParaRPr>
           </a:p>
         </p:txBody>
       </p:sp>
@@ -6709,18 +6558,13 @@
               </a:lnSpc>
             </a:pPr>
             <a:r>
-              <a:rPr lang="en-US" sz="1400" b="0" dirty="0" smtClean="0">
+              <a:rPr lang="en-US" sz="1400" b="0" dirty="0">
                 <a:solidFill>
                   <a:schemeClr val="tx1"/>
                 </a:solidFill>
               </a:rPr>
               <a:t>BBN Components</a:t>
             </a:r>
-            <a:endParaRPr lang="en-US" sz="1400" b="0" dirty="0">
-              <a:solidFill>
-                <a:schemeClr val="tx1"/>
-              </a:solidFill>
-            </a:endParaRPr>
           </a:p>
         </p:txBody>
       </p:sp>
@@ -6768,11 +6612,7 @@
             <a:pPr algn="ctr"/>
             <a:r>
               <a:rPr lang="en-US" sz="1400" dirty="0"/>
-              <a:t>Query Optimizer </a:t>
-            </a:r>
-            <a:r>
-              <a:rPr lang="en-US" sz="1400" dirty="0" smtClean="0"/>
-              <a:t>Customizations</a:t>
+              <a:t>Query Optimizer Customizations</a:t>
             </a:r>
             <a:endParaRPr lang="en-US" sz="1400" b="0" dirty="0">
               <a:solidFill>
@@ -6825,7 +6665,7 @@
           <a:p>
             <a:pPr algn="ctr"/>
             <a:r>
-              <a:rPr lang="en-US" sz="1400" dirty="0" smtClean="0"/>
+              <a:rPr lang="en-US" sz="1400" dirty="0"/>
               <a:t>Admin Interface</a:t>
             </a:r>
             <a:endParaRPr lang="en-US" sz="1400" b="0" dirty="0">
@@ -6846,13 +6686,6 @@
   <p:clrMapOvr>
     <a:masterClrMapping/>
   </p:clrMapOvr>
-  <p:timing>
-    <p:tnLst>
-      <p:par>
-        <p:cTn id="1" dur="indefinite" restart="never" nodeType="tmRoot"/>
-      </p:par>
-    </p:tnLst>
-  </p:timing>
 </p:sld>
 </file>
 
@@ -6889,7 +6722,7 @@
           <a:lstStyle/>
           <a:p>
             <a:r>
-              <a:rPr lang="en-US" sz="4600" dirty="0" smtClean="0"/>
+              <a:rPr lang="en-US" sz="4600" dirty="0"/>
               <a:t>Parliament™ File Structure</a:t>
             </a:r>
             <a:endParaRPr lang="en-US" sz="2000" i="1" dirty="0"/>
@@ -8429,4 +8262,10 @@
   </a:objectDefaults>
   <a:extraClrSchemeLst/>
 </a:theme>
+</file>
+
+<file path=docMetadata/LabelInfo.xml><?xml version="1.0" encoding="utf-8"?>
+<clbl:labelList xmlns:clbl="http://schemas.microsoft.com/office/2020/mipLabelMetadata">
+  <clbl:label id="{4447dd6a-a4a1-440b-a6a3-9124ef1ee017}" enabled="1" method="Privileged" siteId="{7a18110d-ef9b-4274-acef-e62ab0fe28ed}" contentBits="0" removed="0"/>
+</clbl:labelList>
 </file>
</xml_diff>